<commit_message>
Point to safety-trust-engine for testing LLMs and agents
</commit_message>
<xml_diff>
--- a/docs/Adversarial_ML.pptx
+++ b/docs/Adversarial_ML.pptx
@@ -680,7 +680,7 @@
           <a:lstStyle/>
           <a:p>
             <a:r>
-              <a:t>Generative models add a new problem: text is both data and instructions. Direct prompt injection is the user attacking the model. Indirect prompt injection is a third party hiding instructions in content the model reads, which matters most for agents that can call tools and send data out. OWASP's 2025 list for LLM applications puts prompt injection first and also covers sensitive information disclosure, supply chain, poisoning and excessive agency. NIST's advice is to assume prompt injection is possible whenever the model reads untrusted input. This repository has no generative-AI demo; this slide is for orientation.</a:t>
+              <a:t>Generative models add a new problem: text is both data and instructions. Direct prompt injection is the user attacking the model. Indirect prompt injection is a third party hiding instructions in content the model reads, which matters most for agents that can call tools and send data out. OWASP's 2025 list for LLM applications puts prompt injection first and also covers sensitive information disclosure, supply chain, poisoning and excessive agency. NIST's advice is to assume prompt injection is possible whenever the model reads untrusted input. This repository has no generative-AI demo; the companion repository safety-trust-engine runs garak, AgentDojo and PyRIT against a model or agent and fails CI when an attack-success rate passes its tolerance, with each finding mapped to EU AI Act, DORA, FCA and NIST controls.</a:t>
             </a:r>
           </a:p>
         </p:txBody>
@@ -7418,7 +7418,7 @@
                 </a:solidFill>
                 <a:latin typeface="IBM Plex Sans"/>
               </a:rPr>
-              <a:t>NIST AI 100-2e2025 §3.3-3.5. OWASP Top 10 for LLM Applications 2025 (genai.owasp.org). Not demonstrated here.</a:t>
+              <a:t>NIST AI 100-2e2025 §3.3-3.5. OWASP Top 10 for LLM Applications 2025 (genai.owasp.org). LLM tests: olonok69/safety-trust-engine.</a:t>
             </a:r>
           </a:p>
         </p:txBody>
@@ -21299,7 +21299,7 @@
                 </a:solidFill>
                 <a:latin typeface="IBM Plex Sans"/>
               </a:rPr>
-              <a:t>No LLM demo. Prompt injection and agents are covered in slides only.</a:t>
+              <a:t>No LLM demo here. safety-trust-engine tests prompt injection and agents with garak, AgentDojo, PyRIT.</a:t>
             </a:r>
           </a:p>
         </p:txBody>

</xml_diff>

<commit_message>
Document the release gate in the README, the guides and the deck
New guide section 17 in English and Spanish (later sections renumbered),
a release-gate slide (the deck now has 40), and run instructions.
</commit_message>
<xml_diff>
--- a/docs/Adversarial_ML.pptx
+++ b/docs/Adversarial_ML.pptx
@@ -44,6 +44,7 @@
     <p:sldId id="292" r:id="rId44"/>
     <p:sldId id="293" r:id="rId45"/>
     <p:sldId id="294" r:id="rId46"/>
+    <p:sldId id="295" r:id="rId47"/>
   </p:sldIdLst>
   <p:sldSz cx="12191695" cy="6858000" type="screen4x3"/>
   <p:notesSz cx="6858000" cy="9144000"/>
@@ -2710,7 +2711,7 @@
           <a:lstStyle/>
           <a:p>
             <a:r>
-              <a:t>Setup is in the repository README: create a Python 3.11 environment with uv and install demo/requirements.txt, which brings numpy, scikit-learn and sacroml (and PyTorch with it). Demo 3 and demo 1 run in seconds; demo 2 takes a few minutes. The guides in docs/guide walk through every report section by section.</a:t>
+              <a:t>The gate reruns demos 1 and 3, reads the numbers they already print, and judges each regulatory control as pass, fail or not evidenced. The GRAIMATTER controls pass on the wrapped tree. The robustness controls fail on the forest of demo 3: privacy checks alone do not make a model resilient in the sense of Article 15(5), which also names poisoning and evasion. A control whose demo did not run is reported as not evidenced, never as pass; CI declares demo 2 out of scope explicitly because it does not install sacroml. The US pack reads the same evidence through NIST AI RMF MEASURE 2.6, 2.7 and 2.10 and federal model risk guidance, where a classifier fits directly. The tolerances are a risk appetite set for the workshop, and the mapping is this repository's own.</a:t>
             </a:r>
           </a:p>
         </p:txBody>
@@ -2780,7 +2781,7 @@
           <a:lstStyle/>
           <a:p>
             <a:r>
-              <a:t>Both PDFs, the NIST report and the green paper, are in the repository root. The guide, in English and Spanish, follows the same order as these slides and maps each section to its slides in Appendix A.</a:t>
+              <a:t>Setup is in the repository README: create a Python 3.11 environment with uv and install demo/requirements.txt, which brings numpy, scikit-learn and sacroml (and PyTorch with it). Demo 3 and demo 1 run in seconds; demo 2 takes a few minutes. run_gate.py reruns the demos and writes the gate report to demo/output/gate; CI runs it on every pull request. The guides in docs/guide walk through every report section by section.</a:t>
             </a:r>
           </a:p>
         </p:txBody>
@@ -2851,6 +2852,76 @@
           <a:p>
             <a:r>
               <a:t>NIST separates training-time attacks from deployment-time attacks and lists the capabilities an attacker needs. Training data control enables poisoning. Model or source-code control enables model poisoning and supply-chain attacks. Query access enables evasion, extraction and the privacy attacks. GRAIMATTER sits on the right of this picture: the model file and the queries made to it, and only the privacy objective. That is why demo 3 exists: it covers the integrity attacks that a TRE's checks would not see.</a:t>
+            </a:r>
+          </a:p>
+        </p:txBody>
+      </p:sp>
+      <p:sp>
+        <p:nvSpPr>
+          <p:cNvPr id="4" name="Slide Number Placeholder 3"/>
+          <p:cNvSpPr>
+            <a:spLocks noGrp="1"/>
+          </p:cNvSpPr>
+          <p:nvPr>
+            <p:ph type="sldNum" idx="5" sz="quarter"/>
+          </p:nvPr>
+        </p:nvSpPr>
+        <p:spPr/>
+      </p:sp>
+    </p:spTree>
+  </p:cSld>
+  <p:clrMapOvr>
+    <a:masterClrMapping/>
+  </p:clrMapOvr>
+</p:notes>
+</file>
+
+<file path=ppt/notesSlides/notesSlide40.xml><?xml version="1.0" encoding="utf-8"?>
+<p:notes xmlns:a="http://schemas.openxmlformats.org/drawingml/2006/main" xmlns:p="http://schemas.openxmlformats.org/presentationml/2006/main" xmlns:r="http://schemas.openxmlformats.org/officeDocument/2006/relationships">
+  <p:cSld>
+    <p:spTree>
+      <p:nvGrpSpPr>
+        <p:cNvPr id="1" name=""/>
+        <p:cNvGrpSpPr/>
+        <p:nvPr/>
+      </p:nvGrpSpPr>
+      <p:grpSpPr>
+        <a:xfrm>
+          <a:off x="0" y="0"/>
+          <a:ext cx="0" cy="0"/>
+          <a:chOff x="0" y="0"/>
+          <a:chExt cx="0" cy="0"/>
+        </a:xfrm>
+      </p:grpSpPr>
+      <p:sp>
+        <p:nvSpPr>
+          <p:cNvPr id="2" name="Slide Image Placeholder 1"/>
+          <p:cNvSpPr>
+            <a:spLocks noGrp="1"/>
+          </p:cNvSpPr>
+          <p:nvPr>
+            <p:ph type="sldImg" idx="2"/>
+          </p:nvPr>
+        </p:nvSpPr>
+        <p:spPr/>
+      </p:sp>
+      <p:sp>
+        <p:nvSpPr>
+          <p:cNvPr id="3" name="Notes Placeholder 2"/>
+          <p:cNvSpPr>
+            <a:spLocks noGrp="1"/>
+          </p:cNvSpPr>
+          <p:nvPr>
+            <p:ph type="body" idx="3" sz="quarter"/>
+          </p:nvPr>
+        </p:nvSpPr>
+        <p:spPr/>
+        <p:txBody>
+          <a:bodyPr/>
+          <a:lstStyle/>
+          <a:p>
+            <a:r>
+              <a:t>Both PDFs, the NIST report and the green paper, are in the repository root. The guide, in English and Spanish, follows the same order as these slides and maps each section to its slides in Appendix A.</a:t>
             </a:r>
           </a:p>
         </p:txBody>
@@ -21497,7 +21568,7 @@
                 </a:solidFill>
                 <a:latin typeface="IBM Plex Sans"/>
               </a:rPr>
-              <a:t>Three scripts, one environment, reports under demo/output</a:t>
+              <a:t>One gate, four lenses: GRAIMATTER passes, Article 15(5) fails</a:t>
             </a:r>
           </a:p>
         </p:txBody>
@@ -21532,43 +21603,600 @@
                 </a:solidFill>
                 <a:latin typeface="Consolas"/>
               </a:rPr>
-              <a:t>RUN IT YOURSELF</a:t>
-            </a:r>
-          </a:p>
-        </p:txBody>
-      </p:sp>
-      <p:sp>
-        <p:nvSpPr>
-          <p:cNvPr id="4" name="Rounded Rectangle 3"/>
-          <p:cNvSpPr/>
-          <p:nvPr/>
-        </p:nvSpPr>
-        <p:spPr>
-          <a:xfrm>
-            <a:off x="813816" y="2011680"/>
-            <a:ext cx="5669280" cy="3886200"/>
-          </a:xfrm>
-          <a:prstGeom prst="roundRect">
-            <a:avLst>
-              <a:gd name="adj" fmla="val 2823"/>
-            </a:avLst>
-          </a:prstGeom>
-          <a:solidFill>
-            <a:srgbClr val="0F1B2D"/>
-          </a:solidFill>
-          <a:ln>
-            <a:noFill/>
-          </a:ln>
-          <a:effectLst/>
-        </p:spPr>
-        <p:txBody>
-          <a:bodyPr rtlCol="0" anchor="ctr"/>
-          <a:lstStyle/>
-          <a:p>
-            <a:pPr algn="ctr"/>
-          </a:p>
-        </p:txBody>
-      </p:sp>
+              <a:t>RELEASE GATE · DEMO/RUN_GATE.PY · CI</a:t>
+            </a:r>
+          </a:p>
+        </p:txBody>
+      </p:sp>
+      <p:graphicFrame>
+        <p:nvGraphicFramePr>
+          <p:cNvPr id="4" name="Table 3"/>
+          <p:cNvGraphicFramePr>
+            <a:graphicFrameLocks noGrp="1"/>
+          </p:cNvGraphicFramePr>
+          <p:nvPr/>
+        </p:nvGraphicFramePr>
+        <p:xfrm>
+          <a:off x="813816" y="1920240"/>
+          <a:ext cx="6400800" cy="2103120"/>
+        </p:xfrm>
+        <a:graphic>
+          <a:graphicData uri="http://schemas.openxmlformats.org/drawingml/2006/table">
+            <a:tbl>
+              <a:tblPr firstRow="1" bandRow="1">
+                <a:tableStyleId>{5C22544A-7EE6-4342-B048-85BDC9FD1C3A}</a:tableStyleId>
+              </a:tblPr>
+              <a:tblGrid>
+                <a:gridCol w="2377440"/>
+                <a:gridCol w="960120"/>
+                <a:gridCol w="822960"/>
+                <a:gridCol w="822960"/>
+                <a:gridCol w="1417320"/>
+              </a:tblGrid>
+              <a:tr h="420624">
+                <a:tc>
+                  <a:txBody>
+                    <a:bodyPr wrap="square"/>
+                    <a:lstStyle/>
+                    <a:p>
+                      <a:r>
+                        <a:rPr sz="1300" b="1">
+                          <a:solidFill>
+                            <a:srgbClr val="F6F5F0"/>
+                          </a:solidFill>
+                          <a:latin typeface="IBM Plex Sans"/>
+                        </a:rPr>
+                        <a:t>Pack</a:t>
+                      </a:r>
+                    </a:p>
+                  </a:txBody>
+                  <a:tcPr marL="91440" marR="91440" marT="36576" marB="36576" anchor="ctr">
+                    <a:solidFill>
+                      <a:srgbClr val="0F1B2D"/>
+                    </a:solidFill>
+                  </a:tcPr>
+                </a:tc>
+                <a:tc>
+                  <a:txBody>
+                    <a:bodyPr wrap="square"/>
+                    <a:lstStyle/>
+                    <a:p>
+                      <a:r>
+                        <a:rPr sz="1300" b="1">
+                          <a:solidFill>
+                            <a:srgbClr val="F6F5F0"/>
+                          </a:solidFill>
+                          <a:latin typeface="IBM Plex Sans"/>
+                        </a:rPr>
+                        <a:t>Controls</a:t>
+                      </a:r>
+                    </a:p>
+                  </a:txBody>
+                  <a:tcPr marL="91440" marR="91440" marT="36576" marB="36576" anchor="ctr">
+                    <a:solidFill>
+                      <a:srgbClr val="0F1B2D"/>
+                    </a:solidFill>
+                  </a:tcPr>
+                </a:tc>
+                <a:tc>
+                  <a:txBody>
+                    <a:bodyPr wrap="square"/>
+                    <a:lstStyle/>
+                    <a:p>
+                      <a:r>
+                        <a:rPr sz="1300" b="1">
+                          <a:solidFill>
+                            <a:srgbClr val="F6F5F0"/>
+                          </a:solidFill>
+                          <a:latin typeface="IBM Plex Sans"/>
+                        </a:rPr>
+                        <a:t>Pass</a:t>
+                      </a:r>
+                    </a:p>
+                  </a:txBody>
+                  <a:tcPr marL="91440" marR="91440" marT="36576" marB="36576" anchor="ctr">
+                    <a:solidFill>
+                      <a:srgbClr val="0F1B2D"/>
+                    </a:solidFill>
+                  </a:tcPr>
+                </a:tc>
+                <a:tc>
+                  <a:txBody>
+                    <a:bodyPr wrap="square"/>
+                    <a:lstStyle/>
+                    <a:p>
+                      <a:r>
+                        <a:rPr sz="1300" b="1">
+                          <a:solidFill>
+                            <a:srgbClr val="F6F5F0"/>
+                          </a:solidFill>
+                          <a:latin typeface="IBM Plex Sans"/>
+                        </a:rPr>
+                        <a:t>Fail</a:t>
+                      </a:r>
+                    </a:p>
+                  </a:txBody>
+                  <a:tcPr marL="91440" marR="91440" marT="36576" marB="36576" anchor="ctr">
+                    <a:solidFill>
+                      <a:srgbClr val="0F1B2D"/>
+                    </a:solidFill>
+                  </a:tcPr>
+                </a:tc>
+                <a:tc>
+                  <a:txBody>
+                    <a:bodyPr wrap="square"/>
+                    <a:lstStyle/>
+                    <a:p>
+                      <a:r>
+                        <a:rPr sz="1300" b="1">
+                          <a:solidFill>
+                            <a:srgbClr val="F6F5F0"/>
+                          </a:solidFill>
+                          <a:latin typeface="IBM Plex Sans"/>
+                        </a:rPr>
+                        <a:t>Not evidenced</a:t>
+                      </a:r>
+                    </a:p>
+                  </a:txBody>
+                  <a:tcPr marL="91440" marR="91440" marT="36576" marB="36576" anchor="ctr">
+                    <a:solidFill>
+                      <a:srgbClr val="0F1B2D"/>
+                    </a:solidFill>
+                  </a:tcPr>
+                </a:tc>
+              </a:tr>
+              <a:tr h="420624">
+                <a:tc>
+                  <a:txBody>
+                    <a:bodyPr wrap="square"/>
+                    <a:lstStyle/>
+                    <a:p>
+                      <a:r>
+                        <a:rPr sz="1300" b="1">
+                          <a:solidFill>
+                            <a:srgbClr val="0F1B2D"/>
+                          </a:solidFill>
+                          <a:latin typeface="IBM Plex Sans"/>
+                        </a:rPr>
+                        <a:t>EU AI Act 15(5), UK Code</a:t>
+                      </a:r>
+                    </a:p>
+                  </a:txBody>
+                  <a:tcPr marL="91440" marR="91440" marT="36576" marB="36576" anchor="ctr">
+                    <a:solidFill>
+                      <a:srgbClr val="FDFCF9"/>
+                    </a:solidFill>
+                  </a:tcPr>
+                </a:tc>
+                <a:tc>
+                  <a:txBody>
+                    <a:bodyPr wrap="square"/>
+                    <a:lstStyle/>
+                    <a:p>
+                      <a:r>
+                        <a:rPr sz="1300" b="0">
+                          <a:solidFill>
+                            <a:srgbClr val="3A4556"/>
+                          </a:solidFill>
+                          <a:latin typeface="IBM Plex Sans"/>
+                        </a:rPr>
+                        <a:t>6</a:t>
+                      </a:r>
+                    </a:p>
+                  </a:txBody>
+                  <a:tcPr marL="91440" marR="91440" marT="36576" marB="36576" anchor="ctr">
+                    <a:solidFill>
+                      <a:srgbClr val="FDFCF9"/>
+                    </a:solidFill>
+                  </a:tcPr>
+                </a:tc>
+                <a:tc>
+                  <a:txBody>
+                    <a:bodyPr wrap="square"/>
+                    <a:lstStyle/>
+                    <a:p>
+                      <a:r>
+                        <a:rPr sz="1300" b="0">
+                          <a:solidFill>
+                            <a:srgbClr val="3A4556"/>
+                          </a:solidFill>
+                          <a:latin typeface="IBM Plex Sans"/>
+                        </a:rPr>
+                        <a:t>0</a:t>
+                      </a:r>
+                    </a:p>
+                  </a:txBody>
+                  <a:tcPr marL="91440" marR="91440" marT="36576" marB="36576" anchor="ctr">
+                    <a:solidFill>
+                      <a:srgbClr val="FDFCF9"/>
+                    </a:solidFill>
+                  </a:tcPr>
+                </a:tc>
+                <a:tc>
+                  <a:txBody>
+                    <a:bodyPr wrap="square"/>
+                    <a:lstStyle/>
+                    <a:p>
+                      <a:r>
+                        <a:rPr sz="1300" b="0">
+                          <a:solidFill>
+                            <a:srgbClr val="3A4556"/>
+                          </a:solidFill>
+                          <a:latin typeface="IBM Plex Sans"/>
+                        </a:rPr>
+                        <a:t>6</a:t>
+                      </a:r>
+                    </a:p>
+                  </a:txBody>
+                  <a:tcPr marL="91440" marR="91440" marT="36576" marB="36576" anchor="ctr">
+                    <a:solidFill>
+                      <a:srgbClr val="FBE9DC"/>
+                    </a:solidFill>
+                  </a:tcPr>
+                </a:tc>
+                <a:tc>
+                  <a:txBody>
+                    <a:bodyPr wrap="square"/>
+                    <a:lstStyle/>
+                    <a:p>
+                      <a:r>
+                        <a:rPr sz="1300" b="0">
+                          <a:solidFill>
+                            <a:srgbClr val="3A4556"/>
+                          </a:solidFill>
+                          <a:latin typeface="IBM Plex Sans"/>
+                        </a:rPr>
+                        <a:t>0</a:t>
+                      </a:r>
+                    </a:p>
+                  </a:txBody>
+                  <a:tcPr marL="91440" marR="91440" marT="36576" marB="36576" anchor="ctr">
+                    <a:solidFill>
+                      <a:srgbClr val="FDFCF9"/>
+                    </a:solidFill>
+                  </a:tcPr>
+                </a:tc>
+              </a:tr>
+              <a:tr h="420624">
+                <a:tc>
+                  <a:txBody>
+                    <a:bodyPr wrap="square"/>
+                    <a:lstStyle/>
+                    <a:p>
+                      <a:r>
+                        <a:rPr sz="1300" b="1">
+                          <a:solidFill>
+                            <a:srgbClr val="0F1B2D"/>
+                          </a:solidFill>
+                          <a:latin typeface="IBM Plex Sans"/>
+                        </a:rPr>
+                        <a:t>NIST AI 100-2</a:t>
+                      </a:r>
+                    </a:p>
+                  </a:txBody>
+                  <a:tcPr marL="91440" marR="91440" marT="36576" marB="36576" anchor="ctr">
+                    <a:solidFill>
+                      <a:srgbClr val="F1EFE8"/>
+                    </a:solidFill>
+                  </a:tcPr>
+                </a:tc>
+                <a:tc>
+                  <a:txBody>
+                    <a:bodyPr wrap="square"/>
+                    <a:lstStyle/>
+                    <a:p>
+                      <a:r>
+                        <a:rPr sz="1300" b="0">
+                          <a:solidFill>
+                            <a:srgbClr val="3A4556"/>
+                          </a:solidFill>
+                          <a:latin typeface="IBM Plex Sans"/>
+                        </a:rPr>
+                        <a:t>5</a:t>
+                      </a:r>
+                    </a:p>
+                  </a:txBody>
+                  <a:tcPr marL="91440" marR="91440" marT="36576" marB="36576" anchor="ctr">
+                    <a:solidFill>
+                      <a:srgbClr val="F1EFE8"/>
+                    </a:solidFill>
+                  </a:tcPr>
+                </a:tc>
+                <a:tc>
+                  <a:txBody>
+                    <a:bodyPr wrap="square"/>
+                    <a:lstStyle/>
+                    <a:p>
+                      <a:r>
+                        <a:rPr sz="1300" b="0">
+                          <a:solidFill>
+                            <a:srgbClr val="3A4556"/>
+                          </a:solidFill>
+                          <a:latin typeface="IBM Plex Sans"/>
+                        </a:rPr>
+                        <a:t>2</a:t>
+                      </a:r>
+                    </a:p>
+                  </a:txBody>
+                  <a:tcPr marL="91440" marR="91440" marT="36576" marB="36576" anchor="ctr">
+                    <a:solidFill>
+                      <a:srgbClr val="F1EFE8"/>
+                    </a:solidFill>
+                  </a:tcPr>
+                </a:tc>
+                <a:tc>
+                  <a:txBody>
+                    <a:bodyPr wrap="square"/>
+                    <a:lstStyle/>
+                    <a:p>
+                      <a:r>
+                        <a:rPr sz="1300" b="0">
+                          <a:solidFill>
+                            <a:srgbClr val="3A4556"/>
+                          </a:solidFill>
+                          <a:latin typeface="IBM Plex Sans"/>
+                        </a:rPr>
+                        <a:t>3</a:t>
+                      </a:r>
+                    </a:p>
+                  </a:txBody>
+                  <a:tcPr marL="91440" marR="91440" marT="36576" marB="36576" anchor="ctr">
+                    <a:solidFill>
+                      <a:srgbClr val="FBE9DC"/>
+                    </a:solidFill>
+                  </a:tcPr>
+                </a:tc>
+                <a:tc>
+                  <a:txBody>
+                    <a:bodyPr wrap="square"/>
+                    <a:lstStyle/>
+                    <a:p>
+                      <a:r>
+                        <a:rPr sz="1300" b="0">
+                          <a:solidFill>
+                            <a:srgbClr val="3A4556"/>
+                          </a:solidFill>
+                          <a:latin typeface="IBM Plex Sans"/>
+                        </a:rPr>
+                        <a:t>0</a:t>
+                      </a:r>
+                    </a:p>
+                  </a:txBody>
+                  <a:tcPr marL="91440" marR="91440" marT="36576" marB="36576" anchor="ctr">
+                    <a:solidFill>
+                      <a:srgbClr val="F1EFE8"/>
+                    </a:solidFill>
+                  </a:tcPr>
+                </a:tc>
+              </a:tr>
+              <a:tr h="420624">
+                <a:tc>
+                  <a:txBody>
+                    <a:bodyPr wrap="square"/>
+                    <a:lstStyle/>
+                    <a:p>
+                      <a:r>
+                        <a:rPr sz="1300" b="1">
+                          <a:solidFill>
+                            <a:srgbClr val="0F1B2D"/>
+                          </a:solidFill>
+                          <a:latin typeface="IBM Plex Sans"/>
+                        </a:rPr>
+                        <a:t>GRAIMATTER TECH</a:t>
+                      </a:r>
+                    </a:p>
+                  </a:txBody>
+                  <a:tcPr marL="91440" marR="91440" marT="36576" marB="36576" anchor="ctr">
+                    <a:solidFill>
+                      <a:srgbClr val="FDFCF9"/>
+                    </a:solidFill>
+                  </a:tcPr>
+                </a:tc>
+                <a:tc>
+                  <a:txBody>
+                    <a:bodyPr wrap="square"/>
+                    <a:lstStyle/>
+                    <a:p>
+                      <a:r>
+                        <a:rPr sz="1300" b="0">
+                          <a:solidFill>
+                            <a:srgbClr val="3A4556"/>
+                          </a:solidFill>
+                          <a:latin typeface="IBM Plex Sans"/>
+                        </a:rPr>
+                        <a:t>6</a:t>
+                      </a:r>
+                    </a:p>
+                  </a:txBody>
+                  <a:tcPr marL="91440" marR="91440" marT="36576" marB="36576" anchor="ctr">
+                    <a:solidFill>
+                      <a:srgbClr val="FDFCF9"/>
+                    </a:solidFill>
+                  </a:tcPr>
+                </a:tc>
+                <a:tc>
+                  <a:txBody>
+                    <a:bodyPr wrap="square"/>
+                    <a:lstStyle/>
+                    <a:p>
+                      <a:r>
+                        <a:rPr sz="1300" b="0">
+                          <a:solidFill>
+                            <a:srgbClr val="3A4556"/>
+                          </a:solidFill>
+                          <a:latin typeface="IBM Plex Sans"/>
+                        </a:rPr>
+                        <a:t>5</a:t>
+                      </a:r>
+                    </a:p>
+                  </a:txBody>
+                  <a:tcPr marL="91440" marR="91440" marT="36576" marB="36576" anchor="ctr">
+                    <a:solidFill>
+                      <a:srgbClr val="DCEBDD"/>
+                    </a:solidFill>
+                  </a:tcPr>
+                </a:tc>
+                <a:tc>
+                  <a:txBody>
+                    <a:bodyPr wrap="square"/>
+                    <a:lstStyle/>
+                    <a:p>
+                      <a:r>
+                        <a:rPr sz="1300" b="0">
+                          <a:solidFill>
+                            <a:srgbClr val="3A4556"/>
+                          </a:solidFill>
+                          <a:latin typeface="IBM Plex Sans"/>
+                        </a:rPr>
+                        <a:t>0</a:t>
+                      </a:r>
+                    </a:p>
+                  </a:txBody>
+                  <a:tcPr marL="91440" marR="91440" marT="36576" marB="36576" anchor="ctr">
+                    <a:solidFill>
+                      <a:srgbClr val="FDFCF9"/>
+                    </a:solidFill>
+                  </a:tcPr>
+                </a:tc>
+                <a:tc>
+                  <a:txBody>
+                    <a:bodyPr wrap="square"/>
+                    <a:lstStyle/>
+                    <a:p>
+                      <a:r>
+                        <a:rPr sz="1300" b="0">
+                          <a:solidFill>
+                            <a:srgbClr val="3A4556"/>
+                          </a:solidFill>
+                          <a:latin typeface="IBM Plex Sans"/>
+                        </a:rPr>
+                        <a:t>1 (demo 2)</a:t>
+                      </a:r>
+                    </a:p>
+                  </a:txBody>
+                  <a:tcPr marL="91440" marR="91440" marT="36576" marB="36576" anchor="ctr">
+                    <a:solidFill>
+                      <a:srgbClr val="FDFCF9"/>
+                    </a:solidFill>
+                  </a:tcPr>
+                </a:tc>
+              </a:tr>
+              <a:tr h="420624">
+                <a:tc>
+                  <a:txBody>
+                    <a:bodyPr wrap="square"/>
+                    <a:lstStyle/>
+                    <a:p>
+                      <a:r>
+                        <a:rPr sz="1300" b="1">
+                          <a:solidFill>
+                            <a:srgbClr val="0F1B2D"/>
+                          </a:solidFill>
+                          <a:latin typeface="IBM Plex Sans"/>
+                        </a:rPr>
+                        <a:t>NIST AI RMF, SR 26-02</a:t>
+                      </a:r>
+                    </a:p>
+                  </a:txBody>
+                  <a:tcPr marL="91440" marR="91440" marT="36576" marB="36576" anchor="ctr">
+                    <a:solidFill>
+                      <a:srgbClr val="F1EFE8"/>
+                    </a:solidFill>
+                  </a:tcPr>
+                </a:tc>
+                <a:tc>
+                  <a:txBody>
+                    <a:bodyPr wrap="square"/>
+                    <a:lstStyle/>
+                    <a:p>
+                      <a:r>
+                        <a:rPr sz="1300" b="0">
+                          <a:solidFill>
+                            <a:srgbClr val="3A4556"/>
+                          </a:solidFill>
+                          <a:latin typeface="IBM Plex Sans"/>
+                        </a:rPr>
+                        <a:t>6</a:t>
+                      </a:r>
+                    </a:p>
+                  </a:txBody>
+                  <a:tcPr marL="91440" marR="91440" marT="36576" marB="36576" anchor="ctr">
+                    <a:solidFill>
+                      <a:srgbClr val="F1EFE8"/>
+                    </a:solidFill>
+                  </a:tcPr>
+                </a:tc>
+                <a:tc>
+                  <a:txBody>
+                    <a:bodyPr wrap="square"/>
+                    <a:lstStyle/>
+                    <a:p>
+                      <a:r>
+                        <a:rPr sz="1300" b="0">
+                          <a:solidFill>
+                            <a:srgbClr val="3A4556"/>
+                          </a:solidFill>
+                          <a:latin typeface="IBM Plex Sans"/>
+                        </a:rPr>
+                        <a:t>3</a:t>
+                      </a:r>
+                    </a:p>
+                  </a:txBody>
+                  <a:tcPr marL="91440" marR="91440" marT="36576" marB="36576" anchor="ctr">
+                    <a:solidFill>
+                      <a:srgbClr val="F1EFE8"/>
+                    </a:solidFill>
+                  </a:tcPr>
+                </a:tc>
+                <a:tc>
+                  <a:txBody>
+                    <a:bodyPr wrap="square"/>
+                    <a:lstStyle/>
+                    <a:p>
+                      <a:r>
+                        <a:rPr sz="1300" b="0">
+                          <a:solidFill>
+                            <a:srgbClr val="3A4556"/>
+                          </a:solidFill>
+                          <a:latin typeface="IBM Plex Sans"/>
+                        </a:rPr>
+                        <a:t>3</a:t>
+                      </a:r>
+                    </a:p>
+                  </a:txBody>
+                  <a:tcPr marL="91440" marR="91440" marT="36576" marB="36576" anchor="ctr">
+                    <a:solidFill>
+                      <a:srgbClr val="FBE9DC"/>
+                    </a:solidFill>
+                  </a:tcPr>
+                </a:tc>
+                <a:tc>
+                  <a:txBody>
+                    <a:bodyPr wrap="square"/>
+                    <a:lstStyle/>
+                    <a:p>
+                      <a:r>
+                        <a:rPr sz="1300" b="0">
+                          <a:solidFill>
+                            <a:srgbClr val="3A4556"/>
+                          </a:solidFill>
+                          <a:latin typeface="IBM Plex Sans"/>
+                        </a:rPr>
+                        <a:t>0</a:t>
+                      </a:r>
+                    </a:p>
+                  </a:txBody>
+                  <a:tcPr marL="91440" marR="91440" marT="36576" marB="36576" anchor="ctr">
+                    <a:solidFill>
+                      <a:srgbClr val="F1EFE8"/>
+                    </a:solidFill>
+                  </a:tcPr>
+                </a:tc>
+              </a:tr>
+            </a:tbl>
+          </a:graphicData>
+        </a:graphic>
+      </p:graphicFrame>
       <p:sp>
         <p:nvSpPr>
           <p:cNvPr id="5" name="TextBox 4"/>
@@ -21577,8 +22205,8 @@
         </p:nvSpPr>
         <p:spPr>
           <a:xfrm>
-            <a:off x="1088136" y="2194560"/>
-            <a:ext cx="5212080" cy="3566160"/>
+            <a:off x="813816" y="4114800"/>
+            <a:ext cx="6400800" cy="1188720"/>
           </a:xfrm>
           <a:prstGeom prst="rect">
             <a:avLst/>
@@ -21593,13 +22221,22 @@
           <a:p>
             <a:pPr algn="l"/>
             <a:r>
-              <a:rPr sz="1350" b="0" i="0">
-                <a:solidFill>
-                  <a:srgbClr val="F6F5F0"/>
-                </a:solidFill>
-                <a:latin typeface="Consolas"/>
-              </a:rPr>
-              <a:t>uv venv --python 3.11</a:t>
+              <a:rPr sz="1300" b="1" i="0">
+                <a:solidFill>
+                  <a:srgbClr val="3A4556"/>
+                </a:solidFill>
+                <a:latin typeface="IBM Plex Sans"/>
+              </a:rPr>
+              <a:t>Breached: </a:t>
+            </a:r>
+            <a:r>
+              <a:rPr sz="1300" b="0" i="0">
+                <a:solidFill>
+                  <a:srgbClr val="3A4556"/>
+                </a:solidFill>
+                <a:latin typeface="IBM Plex Sans"/>
+              </a:rPr>
+              <a:t>evasion 78.7% (tolerance 10%), a copy agreeing 86.9% after one 200-row budget (80%), a backdoor lifting trigger success by 71.7 points (tolerance 10).</a:t>
             </a:r>
           </a:p>
           <a:p>
@@ -21609,157 +22246,22 @@
               </a:spcBef>
             </a:pPr>
             <a:r>
-              <a:rPr sz="1350" b="0" i="0">
-                <a:solidFill>
-                  <a:srgbClr val="F6F5F0"/>
-                </a:solidFill>
-                <a:latin typeface="Consolas"/>
-              </a:rPr>
-              <a:t>uv pip install -r demo/requirements.txt</a:t>
-            </a:r>
-          </a:p>
-          <a:p>
-            <a:pPr algn="l">
-              <a:spcBef>
-                <a:spcPts val="600"/>
-              </a:spcBef>
-            </a:pPr>
-            <a:r>
-              <a:rPr sz="1350" b="0" i="0">
-                <a:solidFill>
-                  <a:srgbClr val="F6F5F0"/>
-                </a:solidFill>
-                <a:latin typeface="Consolas"/>
-              </a:rPr>
-              <a:t/>
-            </a:r>
-          </a:p>
-          <a:p>
-            <a:pPr algn="l">
-              <a:spcBef>
-                <a:spcPts val="600"/>
-              </a:spcBef>
-            </a:pPr>
-            <a:r>
-              <a:rPr sz="1350" b="0" i="0">
-                <a:solidFill>
-                  <a:srgbClr val="F6F5F0"/>
-                </a:solidFill>
-                <a:latin typeface="Consolas"/>
-              </a:rPr>
-              <a:t>uv run python demo/run_aml_demo.py</a:t>
-            </a:r>
-          </a:p>
-          <a:p>
-            <a:pPr algn="l">
-              <a:spcBef>
-                <a:spcPts val="600"/>
-              </a:spcBef>
-            </a:pPr>
-            <a:r>
-              <a:rPr sz="1350" b="0" i="0">
-                <a:solidFill>
-                  <a:srgbClr val="F6F5F0"/>
-                </a:solidFill>
-                <a:latin typeface="Consolas"/>
-              </a:rPr>
-              <a:t>uv run python demo/run_demo.py</a:t>
-            </a:r>
-          </a:p>
-          <a:p>
-            <a:pPr algn="l">
-              <a:spcBef>
-                <a:spcPts val="600"/>
-              </a:spcBef>
-            </a:pPr>
-            <a:r>
-              <a:rPr sz="1350" b="0" i="0">
-                <a:solidFill>
-                  <a:srgbClr val="F6F5F0"/>
-                </a:solidFill>
-                <a:latin typeface="Consolas"/>
-              </a:rPr>
-              <a:t>uv run python demo/run_sacroml_demo.py</a:t>
-            </a:r>
-          </a:p>
-          <a:p>
-            <a:pPr algn="l">
-              <a:spcBef>
-                <a:spcPts val="600"/>
-              </a:spcBef>
-            </a:pPr>
-            <a:r>
-              <a:rPr sz="1350" b="0" i="0">
-                <a:solidFill>
-                  <a:srgbClr val="F6F5F0"/>
-                </a:solidFill>
-                <a:latin typeface="Consolas"/>
-              </a:rPr>
-              <a:t/>
-            </a:r>
-          </a:p>
-          <a:p>
-            <a:pPr algn="l">
-              <a:spcBef>
-                <a:spcPts val="600"/>
-              </a:spcBef>
-            </a:pPr>
-            <a:r>
-              <a:rPr sz="1350" b="0" i="0">
-                <a:solidFill>
-                  <a:srgbClr val="F6F5F0"/>
-                </a:solidFill>
-                <a:latin typeface="Consolas"/>
-              </a:rPr>
-              <a:t># figures and this deck</a:t>
-            </a:r>
-          </a:p>
-          <a:p>
-            <a:pPr algn="l">
-              <a:spcBef>
-                <a:spcPts val="600"/>
-              </a:spcBef>
-            </a:pPr>
-            <a:r>
-              <a:rPr sz="1350" b="0" i="0">
-                <a:solidFill>
-                  <a:srgbClr val="F6F5F0"/>
-                </a:solidFill>
-                <a:latin typeface="Consolas"/>
-              </a:rPr>
-              <a:t>python docs/guide/make_figures.py</a:t>
-            </a:r>
-          </a:p>
-          <a:p>
-            <a:pPr algn="l">
-              <a:spcBef>
-                <a:spcPts val="600"/>
-              </a:spcBef>
-            </a:pPr>
-            <a:r>
-              <a:rPr sz="1350" b="0" i="0">
-                <a:solidFill>
-                  <a:srgbClr val="F6F5F0"/>
-                </a:solidFill>
-                <a:latin typeface="Consolas"/>
-              </a:rPr>
-              <a:t>python docs/guide/make_aml_figures.py</a:t>
-            </a:r>
-          </a:p>
-          <a:p>
-            <a:pPr algn="l">
-              <a:spcBef>
-                <a:spcPts val="600"/>
-              </a:spcBef>
-            </a:pPr>
-            <a:r>
-              <a:rPr sz="1350" b="0" i="0">
-                <a:solidFill>
-                  <a:srgbClr val="F6F5F0"/>
-                </a:solidFill>
-                <a:latin typeface="Consolas"/>
-              </a:rPr>
-              <a:t>python docs/make_deck.py</a:t>
+              <a:rPr sz="1300" b="1" i="0">
+                <a:solidFill>
+                  <a:srgbClr val="3A4556"/>
+                </a:solidFill>
+                <a:latin typeface="IBM Plex Sans"/>
+              </a:rPr>
+              <a:t>Within: </a:t>
+            </a:r>
+            <a:r>
+              <a:rPr sz="1300" b="0" i="0">
+                <a:solidFill>
+                  <a:srgbClr val="3A4556"/>
+                </a:solidFill>
+                <a:latin typeface="IBM Plex Sans"/>
+              </a:rPr>
+              <a:t>membership, attribute, holdout gap, stored rows, release checks, query budget.</a:t>
             </a:r>
           </a:p>
         </p:txBody>
@@ -21772,12 +22274,12 @@
         </p:nvSpPr>
         <p:spPr>
           <a:xfrm>
-            <a:off x="6757416" y="2011680"/>
-            <a:ext cx="4617720" cy="1188720"/>
+            <a:off x="7534656" y="1920240"/>
+            <a:ext cx="3840480" cy="1874519"/>
           </a:xfrm>
           <a:prstGeom prst="roundRect">
             <a:avLst>
-              <a:gd name="adj" fmla="val 8000"/>
+              <a:gd name="adj" fmla="val 5853"/>
             </a:avLst>
           </a:prstGeom>
           <a:solidFill>
@@ -21806,8 +22308,8 @@
         </p:nvSpPr>
         <p:spPr>
           <a:xfrm>
-            <a:off x="6958583" y="2194560"/>
-            <a:ext cx="4215383" cy="365760"/>
+            <a:off x="7735824" y="2103120"/>
+            <a:ext cx="3438144" cy="365760"/>
           </a:xfrm>
           <a:prstGeom prst="rect">
             <a:avLst/>
@@ -21828,7 +22330,7 @@
                 </a:solidFill>
                 <a:latin typeface="IBM Plex Sans"/>
               </a:rPr>
-              <a:t>Demo 3 · seconds</a:t>
+              <a:t>Never a silent green</a:t>
             </a:r>
           </a:p>
         </p:txBody>
@@ -21841,8 +22343,8 @@
         </p:nvSpPr>
         <p:spPr>
           <a:xfrm>
-            <a:off x="6958583" y="2468880"/>
-            <a:ext cx="4215383" cy="640080"/>
+            <a:off x="7735824" y="2377440"/>
+            <a:ext cx="3438144" cy="1325879"/>
           </a:xfrm>
           <a:prstGeom prst="rect">
             <a:avLst/>
@@ -21863,7 +22365,7 @@
                 </a:solidFill>
                 <a:latin typeface="IBM Plex Sans"/>
               </a:rPr>
-              <a:t>aml_report.txt: evasion, extraction, backdoor.</a:t>
+              <a:t>A control whose demo did not run is not_evidenced, not pass. CI does not install sacroml, so it declares demo 2 out of scope with --accept-missing 2 and the report says so.</a:t>
             </a:r>
           </a:p>
         </p:txBody>
@@ -21876,21 +22378,19 @@
         </p:nvSpPr>
         <p:spPr>
           <a:xfrm>
-            <a:off x="6757416" y="3337560"/>
-            <a:ext cx="4617720" cy="1188720"/>
+            <a:off x="7534656" y="3931920"/>
+            <a:ext cx="3840480" cy="1874519"/>
           </a:xfrm>
           <a:prstGeom prst="roundRect">
             <a:avLst>
-              <a:gd name="adj" fmla="val 8000"/>
+              <a:gd name="adj" fmla="val 5853"/>
             </a:avLst>
           </a:prstGeom>
           <a:solidFill>
-            <a:srgbClr val="FDFCF9"/>
+            <a:srgbClr val="0F1B2D"/>
           </a:solidFill>
-          <a:ln w="12700">
-            <a:solidFill>
-              <a:srgbClr val="E2DFD6"/>
-            </a:solidFill>
+          <a:ln>
+            <a:noFill/>
           </a:ln>
           <a:effectLst/>
         </p:spPr>
@@ -21910,8 +22410,8 @@
         </p:nvSpPr>
         <p:spPr>
           <a:xfrm>
-            <a:off x="6958583" y="3520440"/>
-            <a:ext cx="4215383" cy="365760"/>
+            <a:off x="7735824" y="4114800"/>
+            <a:ext cx="3438144" cy="365760"/>
           </a:xfrm>
           <a:prstGeom prst="rect">
             <a:avLst/>
@@ -21928,11 +22428,11 @@
             <a:r>
               <a:rPr sz="1600" b="1" i="0">
                 <a:solidFill>
-                  <a:srgbClr val="0F1B2D"/>
+                  <a:srgbClr val="F2A35E"/>
                 </a:solidFill>
                 <a:latin typeface="IBM Plex Sans"/>
               </a:rPr>
-              <a:t>Demo 1 · seconds</a:t>
+              <a:t>Read with SR 26-02</a:t>
             </a:r>
           </a:p>
         </p:txBody>
@@ -21945,8 +22445,8 @@
         </p:nvSpPr>
         <p:spPr>
           <a:xfrm>
-            <a:off x="6958583" y="3794760"/>
-            <a:ext cx="4215383" cy="640080"/>
+            <a:off x="7735824" y="4389120"/>
+            <a:ext cx="3438144" cy="1325879"/>
           </a:xfrm>
           <a:prstGeom prst="rect">
             <a:avLst/>
@@ -21963,59 +22463,25 @@
             <a:r>
               <a:rPr sz="1250" b="0" i="0">
                 <a:solidFill>
-                  <a:srgbClr val="3A4556"/>
+                  <a:srgbClr val="D9DEE6"/>
                 </a:solidFill>
                 <a:latin typeface="IBM Plex Sans"/>
               </a:rPr>
-              <a:t>demo_report.txt, data dictionary, register entry, pipeline snapshot, release reports.</a:t>
-            </a:r>
-          </a:p>
-        </p:txBody>
-      </p:sp>
-      <p:sp>
-        <p:nvSpPr>
-          <p:cNvPr id="12" name="Rounded Rectangle 11"/>
-          <p:cNvSpPr/>
-          <p:nvPr/>
-        </p:nvSpPr>
-        <p:spPr>
-          <a:xfrm>
-            <a:off x="6757416" y="4663440"/>
-            <a:ext cx="4617720" cy="1234440"/>
-          </a:xfrm>
-          <a:prstGeom prst="roundRect">
-            <a:avLst>
-              <a:gd name="adj" fmla="val 8000"/>
-            </a:avLst>
-          </a:prstGeom>
-          <a:solidFill>
-            <a:srgbClr val="FDFCF9"/>
-          </a:solidFill>
-          <a:ln w="12700">
-            <a:solidFill>
-              <a:srgbClr val="E2DFD6"/>
-            </a:solidFill>
-          </a:ln>
-          <a:effectLst/>
-        </p:spPr>
-        <p:txBody>
-          <a:bodyPr rtlCol="0" anchor="ctr"/>
-          <a:lstStyle/>
-          <a:p>
-            <a:pPr algn="ctr"/>
-          </a:p>
-        </p:txBody>
-      </p:sp>
-      <p:sp>
-        <p:nvSpPr>
-          <p:cNvPr id="13" name="TextBox 12"/>
+              <a:t>A risk classifier is a model in the plain sense of model risk guidance. The TRE holdout (TECH 6) is the independent validation; the gate in CI is the ongoing monitoring.</a:t>
+            </a:r>
+          </a:p>
+        </p:txBody>
+      </p:sp>
+      <p:sp>
+        <p:nvSpPr>
+          <p:cNvPr id="12" name="TextBox 11"/>
           <p:cNvSpPr txBox="1"/>
           <p:nvPr/>
         </p:nvSpPr>
         <p:spPr>
           <a:xfrm>
-            <a:off x="6958583" y="4846320"/>
-            <a:ext cx="4215383" cy="365760"/>
+            <a:off x="813816" y="6236208"/>
+            <a:ext cx="10561320" cy="274320"/>
           </a:xfrm>
           <a:prstGeom prst="rect">
             <a:avLst/>
@@ -22030,83 +22496,13 @@
           <a:p>
             <a:pPr algn="l"/>
             <a:r>
-              <a:rPr sz="1600" b="1" i="0">
-                <a:solidFill>
-                  <a:srgbClr val="0F1B2D"/>
+              <a:rPr sz="1200" b="0" i="0">
+                <a:solidFill>
+                  <a:srgbClr val="5F6979"/>
                 </a:solidFill>
                 <a:latin typeface="IBM Plex Sans"/>
               </a:rPr>
-              <a:t>Demo 2 · a few minutes</a:t>
-            </a:r>
-          </a:p>
-        </p:txBody>
-      </p:sp>
-      <p:sp>
-        <p:nvSpPr>
-          <p:cNvPr id="14" name="TextBox 13"/>
-          <p:cNvSpPr txBox="1"/>
-          <p:nvPr/>
-        </p:nvSpPr>
-        <p:spPr>
-          <a:xfrm>
-            <a:off x="6958583" y="5120640"/>
-            <a:ext cx="4215383" cy="685800"/>
-          </a:xfrm>
-          <a:prstGeom prst="rect">
-            <a:avLst/>
-          </a:prstGeom>
-          <a:noFill/>
-        </p:spPr>
-        <p:txBody>
-          <a:bodyPr wrap="square" anchor="t" lIns="0" rIns="0" tIns="0" bIns="0">
-            <a:spAutoFit/>
-          </a:bodyPr>
-          <a:lstStyle/>
-          <a:p>
-            <a:pPr algn="l"/>
-            <a:r>
-              <a:rPr sz="1250" b="0" i="0">
-                <a:solidFill>
-                  <a:srgbClr val="3A4556"/>
-                </a:solidFill>
-                <a:latin typeface="IBM Plex Sans"/>
-              </a:rPr>
-              <a:t>sacroml/sacroml_report.txt; report.json and report.pdf per attack.</a:t>
-            </a:r>
-          </a:p>
-        </p:txBody>
-      </p:sp>
-      <p:sp>
-        <p:nvSpPr>
-          <p:cNvPr id="15" name="TextBox 14"/>
-          <p:cNvSpPr txBox="1"/>
-          <p:nvPr/>
-        </p:nvSpPr>
-        <p:spPr>
-          <a:xfrm>
-            <a:off x="813816" y="6236208"/>
-            <a:ext cx="10561320" cy="274320"/>
-          </a:xfrm>
-          <a:prstGeom prst="rect">
-            <a:avLst/>
-          </a:prstGeom>
-          <a:noFill/>
-        </p:spPr>
-        <p:txBody>
-          <a:bodyPr wrap="square" anchor="t" lIns="0" rIns="0" tIns="0" bIns="0">
-            <a:spAutoFit/>
-          </a:bodyPr>
-          <a:lstStyle/>
-          <a:p>
-            <a:pPr algn="l"/>
-            <a:r>
-              <a:rPr sz="1200" b="0" i="0">
-                <a:solidFill>
-                  <a:srgbClr val="5F6979"/>
-                </a:solidFill>
-                <a:latin typeface="IBM Plex Sans"/>
-              </a:rPr>
-              <a:t>Setup details: README.md. Section notes: demo/README.md. Guides: docs/guide/ (English and Spanish).</a:t>
+              <a:t>Tolerances are a demo risk appetite (ELA 8), not official cut-offs. Pattern from safety-trust-engine. demo/output/gate/.</a:t>
             </a:r>
           </a:p>
         </p:txBody>
@@ -22165,7 +22561,7 @@
                 </a:solidFill>
                 <a:latin typeface="IBM Plex Sans"/>
               </a:rPr>
-              <a:t>Read further</a:t>
+              <a:t>Three demos and a gate, reports under demo/output</a:t>
             </a:r>
           </a:p>
         </p:txBody>
@@ -22200,21 +22596,53 @@
                 </a:solidFill>
                 <a:latin typeface="Consolas"/>
               </a:rPr>
-              <a:t>REFERENCES</a:t>
-            </a:r>
-          </a:p>
-        </p:txBody>
-      </p:sp>
-      <p:sp>
-        <p:nvSpPr>
-          <p:cNvPr id="4" name="TextBox 3"/>
+              <a:t>RUN IT YOURSELF</a:t>
+            </a:r>
+          </a:p>
+        </p:txBody>
+      </p:sp>
+      <p:sp>
+        <p:nvSpPr>
+          <p:cNvPr id="4" name="Rounded Rectangle 3"/>
+          <p:cNvSpPr/>
+          <p:nvPr/>
+        </p:nvSpPr>
+        <p:spPr>
+          <a:xfrm>
+            <a:off x="813816" y="2011680"/>
+            <a:ext cx="5669280" cy="3886200"/>
+          </a:xfrm>
+          <a:prstGeom prst="roundRect">
+            <a:avLst>
+              <a:gd name="adj" fmla="val 2823"/>
+            </a:avLst>
+          </a:prstGeom>
+          <a:solidFill>
+            <a:srgbClr val="0F1B2D"/>
+          </a:solidFill>
+          <a:ln>
+            <a:noFill/>
+          </a:ln>
+          <a:effectLst/>
+        </p:spPr>
+        <p:txBody>
+          <a:bodyPr rtlCol="0" anchor="ctr"/>
+          <a:lstStyle/>
+          <a:p>
+            <a:pPr algn="ctr"/>
+          </a:p>
+        </p:txBody>
+      </p:sp>
+      <p:sp>
+        <p:nvSpPr>
+          <p:cNvPr id="5" name="TextBox 4"/>
           <p:cNvSpPr txBox="1"/>
           <p:nvPr/>
         </p:nvSpPr>
         <p:spPr>
           <a:xfrm>
-            <a:off x="813816" y="1920240"/>
-            <a:ext cx="10561320" cy="4206240"/>
+            <a:off x="1088136" y="2194560"/>
+            <a:ext cx="5212080" cy="3566160"/>
           </a:xfrm>
           <a:prstGeom prst="rect">
             <a:avLst/>
@@ -22229,22 +22657,13 @@
           <a:p>
             <a:pPr algn="l"/>
             <a:r>
-              <a:rPr sz="1350" b="1" i="0">
-                <a:solidFill>
-                  <a:srgbClr val="3A4556"/>
-                </a:solidFill>
-                <a:latin typeface="IBM Plex Sans"/>
-              </a:rPr>
-              <a:t>NIST AI 100-2e2025. </a:t>
-            </a:r>
-            <a:r>
-              <a:rPr sz="1350" b="0" i="0">
-                <a:solidFill>
-                  <a:srgbClr val="3A4556"/>
-                </a:solidFill>
-                <a:latin typeface="IBM Plex Sans"/>
-              </a:rPr>
-              <a:t>Vassilev, Oprea, Fordyce, Anderson, Davies, Hamin. Adversarial Machine Learning: A Taxonomy and Terminology of Attacks and Mitigations. March 2025. doi:10.6028/NIST.AI.100-2e2025 (in this repository).</a:t>
+              <a:rPr sz="1250" b="0" i="0">
+                <a:solidFill>
+                  <a:srgbClr val="F6F5F0"/>
+                </a:solidFill>
+                <a:latin typeface="Consolas"/>
+              </a:rPr>
+              <a:t>uv venv --python 3.11</a:t>
             </a:r>
           </a:p>
           <a:p>
@@ -22254,22 +22673,13 @@
               </a:spcBef>
             </a:pPr>
             <a:r>
-              <a:rPr sz="1350" b="1" i="0">
-                <a:solidFill>
-                  <a:srgbClr val="3A4556"/>
-                </a:solidFill>
-                <a:latin typeface="IBM Plex Sans"/>
-              </a:rPr>
-              <a:t>MITRE ATLAS. </a:t>
-            </a:r>
-            <a:r>
-              <a:rPr sz="1350" b="0" i="0">
-                <a:solidFill>
-                  <a:srgbClr val="3A4556"/>
-                </a:solidFill>
-                <a:latin typeface="IBM Plex Sans"/>
-              </a:rPr>
-              <a:t>atlas.mitre.org, data release 2026.09.</a:t>
+              <a:rPr sz="1250" b="0" i="0">
+                <a:solidFill>
+                  <a:srgbClr val="F6F5F0"/>
+                </a:solidFill>
+                <a:latin typeface="Consolas"/>
+              </a:rPr>
+              <a:t>uv pip install -r demo/requirements.txt</a:t>
             </a:r>
           </a:p>
           <a:p>
@@ -22279,22 +22689,13 @@
               </a:spcBef>
             </a:pPr>
             <a:r>
-              <a:rPr sz="1350" b="1" i="0">
-                <a:solidFill>
-                  <a:srgbClr val="3A4556"/>
-                </a:solidFill>
-                <a:latin typeface="IBM Plex Sans"/>
-              </a:rPr>
-              <a:t>OWASP. </a:t>
-            </a:r>
-            <a:r>
-              <a:rPr sz="1350" b="0" i="0">
-                <a:solidFill>
-                  <a:srgbClr val="3A4556"/>
-                </a:solidFill>
-                <a:latin typeface="IBM Plex Sans"/>
-              </a:rPr>
-              <a:t>Machine Learning Security Top 10 (2023, draft); Top 10 for LLM Applications 2025.</a:t>
+              <a:rPr sz="1250" b="0" i="0">
+                <a:solidFill>
+                  <a:srgbClr val="F6F5F0"/>
+                </a:solidFill>
+                <a:latin typeface="Consolas"/>
+              </a:rPr>
+              <a:t/>
             </a:r>
           </a:p>
           <a:p>
@@ -22304,22 +22705,13 @@
               </a:spcBef>
             </a:pPr>
             <a:r>
-              <a:rPr sz="1350" b="1" i="0">
-                <a:solidFill>
-                  <a:srgbClr val="3A4556"/>
-                </a:solidFill>
-                <a:latin typeface="IBM Plex Sans"/>
-              </a:rPr>
-              <a:t>EU. </a:t>
-            </a:r>
-            <a:r>
-              <a:rPr sz="1350" b="0" i="0">
-                <a:solidFill>
-                  <a:srgbClr val="3A4556"/>
-                </a:solidFill>
-                <a:latin typeface="IBM Plex Sans"/>
-              </a:rPr>
-              <a:t>Regulation (EU) 2024/1689 (AI Act), Art. 15; Regulation (EU) 2026/1744 (Digital Omnibus on AI); EDPB Opinion 28/2024 on AI models.</a:t>
+              <a:rPr sz="1250" b="0" i="0">
+                <a:solidFill>
+                  <a:srgbClr val="F6F5F0"/>
+                </a:solidFill>
+                <a:latin typeface="Consolas"/>
+              </a:rPr>
+              <a:t>uv run python demo/run_aml_demo.py</a:t>
             </a:r>
           </a:p>
           <a:p>
@@ -22329,22 +22721,13 @@
               </a:spcBef>
             </a:pPr>
             <a:r>
-              <a:rPr sz="1350" b="1" i="0">
-                <a:solidFill>
-                  <a:srgbClr val="3A4556"/>
-                </a:solidFill>
-                <a:latin typeface="IBM Plex Sans"/>
-              </a:rPr>
-              <a:t>UK. </a:t>
-            </a:r>
-            <a:r>
-              <a:rPr sz="1350" b="0" i="0">
-                <a:solidFill>
-                  <a:srgbClr val="3A4556"/>
-                </a:solidFill>
-                <a:latin typeface="IBM Plex Sans"/>
-              </a:rPr>
-              <a:t>DSIT Code of Practice for the Cyber Security of AI (Jan 2025); ETSI EN 304 223 (Jan 2026); NCSC and CISA, Guidelines for secure AI system development (Nov 2023).</a:t>
+              <a:rPr sz="1250" b="0" i="0">
+                <a:solidFill>
+                  <a:srgbClr val="F6F5F0"/>
+                </a:solidFill>
+                <a:latin typeface="Consolas"/>
+              </a:rPr>
+              <a:t>uv run python demo/run_demo.py</a:t>
             </a:r>
           </a:p>
           <a:p>
@@ -22354,22 +22737,456 @@
               </a:spcBef>
             </a:pPr>
             <a:r>
-              <a:rPr sz="1350" b="1" i="0">
+              <a:rPr sz="1250" b="0" i="0">
+                <a:solidFill>
+                  <a:srgbClr val="F6F5F0"/>
+                </a:solidFill>
+                <a:latin typeface="Consolas"/>
+              </a:rPr>
+              <a:t>uv run python demo/run_sacroml_demo.py</a:t>
+            </a:r>
+          </a:p>
+          <a:p>
+            <a:pPr algn="l">
+              <a:spcBef>
+                <a:spcPts val="600"/>
+              </a:spcBef>
+            </a:pPr>
+            <a:r>
+              <a:rPr sz="1250" b="0" i="0">
+                <a:solidFill>
+                  <a:srgbClr val="F6F5F0"/>
+                </a:solidFill>
+                <a:latin typeface="Consolas"/>
+              </a:rPr>
+              <a:t>uv run python demo/run_gate.py</a:t>
+            </a:r>
+          </a:p>
+          <a:p>
+            <a:pPr algn="l">
+              <a:spcBef>
+                <a:spcPts val="600"/>
+              </a:spcBef>
+            </a:pPr>
+            <a:r>
+              <a:rPr sz="1250" b="0" i="0">
+                <a:solidFill>
+                  <a:srgbClr val="F6F5F0"/>
+                </a:solidFill>
+                <a:latin typeface="Consolas"/>
+              </a:rPr>
+              <a:t/>
+            </a:r>
+          </a:p>
+          <a:p>
+            <a:pPr algn="l">
+              <a:spcBef>
+                <a:spcPts val="600"/>
+              </a:spcBef>
+            </a:pPr>
+            <a:r>
+              <a:rPr sz="1250" b="0" i="0">
+                <a:solidFill>
+                  <a:srgbClr val="F6F5F0"/>
+                </a:solidFill>
+                <a:latin typeface="Consolas"/>
+              </a:rPr>
+              <a:t># figures and this deck</a:t>
+            </a:r>
+          </a:p>
+          <a:p>
+            <a:pPr algn="l">
+              <a:spcBef>
+                <a:spcPts val="600"/>
+              </a:spcBef>
+            </a:pPr>
+            <a:r>
+              <a:rPr sz="1250" b="0" i="0">
+                <a:solidFill>
+                  <a:srgbClr val="F6F5F0"/>
+                </a:solidFill>
+                <a:latin typeface="Consolas"/>
+              </a:rPr>
+              <a:t>python docs/guide/make_figures.py</a:t>
+            </a:r>
+          </a:p>
+          <a:p>
+            <a:pPr algn="l">
+              <a:spcBef>
+                <a:spcPts val="600"/>
+              </a:spcBef>
+            </a:pPr>
+            <a:r>
+              <a:rPr sz="1250" b="0" i="0">
+                <a:solidFill>
+                  <a:srgbClr val="F6F5F0"/>
+                </a:solidFill>
+                <a:latin typeface="Consolas"/>
+              </a:rPr>
+              <a:t>python docs/guide/make_aml_figures.py</a:t>
+            </a:r>
+          </a:p>
+          <a:p>
+            <a:pPr algn="l">
+              <a:spcBef>
+                <a:spcPts val="600"/>
+              </a:spcBef>
+            </a:pPr>
+            <a:r>
+              <a:rPr sz="1250" b="0" i="0">
+                <a:solidFill>
+                  <a:srgbClr val="F6F5F0"/>
+                </a:solidFill>
+                <a:latin typeface="Consolas"/>
+              </a:rPr>
+              <a:t>python docs/make_deck.py</a:t>
+            </a:r>
+          </a:p>
+        </p:txBody>
+      </p:sp>
+      <p:sp>
+        <p:nvSpPr>
+          <p:cNvPr id="6" name="Rounded Rectangle 5"/>
+          <p:cNvSpPr/>
+          <p:nvPr/>
+        </p:nvSpPr>
+        <p:spPr>
+          <a:xfrm>
+            <a:off x="6757416" y="2011680"/>
+            <a:ext cx="4617720" cy="1188720"/>
+          </a:xfrm>
+          <a:prstGeom prst="roundRect">
+            <a:avLst>
+              <a:gd name="adj" fmla="val 8000"/>
+            </a:avLst>
+          </a:prstGeom>
+          <a:solidFill>
+            <a:srgbClr val="FDFCF9"/>
+          </a:solidFill>
+          <a:ln w="12700">
+            <a:solidFill>
+              <a:srgbClr val="E2DFD6"/>
+            </a:solidFill>
+          </a:ln>
+          <a:effectLst/>
+        </p:spPr>
+        <p:txBody>
+          <a:bodyPr rtlCol="0" anchor="ctr"/>
+          <a:lstStyle/>
+          <a:p>
+            <a:pPr algn="ctr"/>
+          </a:p>
+        </p:txBody>
+      </p:sp>
+      <p:sp>
+        <p:nvSpPr>
+          <p:cNvPr id="7" name="TextBox 6"/>
+          <p:cNvSpPr txBox="1"/>
+          <p:nvPr/>
+        </p:nvSpPr>
+        <p:spPr>
+          <a:xfrm>
+            <a:off x="6958583" y="2194560"/>
+            <a:ext cx="4215383" cy="365760"/>
+          </a:xfrm>
+          <a:prstGeom prst="rect">
+            <a:avLst/>
+          </a:prstGeom>
+          <a:noFill/>
+        </p:spPr>
+        <p:txBody>
+          <a:bodyPr wrap="square" anchor="t" lIns="0" rIns="0" tIns="0" bIns="0">
+            <a:spAutoFit/>
+          </a:bodyPr>
+          <a:lstStyle/>
+          <a:p>
+            <a:pPr algn="l"/>
+            <a:r>
+              <a:rPr sz="1600" b="1" i="0">
+                <a:solidFill>
+                  <a:srgbClr val="0F1B2D"/>
+                </a:solidFill>
+                <a:latin typeface="IBM Plex Sans"/>
+              </a:rPr>
+              <a:t>Demo 3 · seconds</a:t>
+            </a:r>
+          </a:p>
+        </p:txBody>
+      </p:sp>
+      <p:sp>
+        <p:nvSpPr>
+          <p:cNvPr id="8" name="TextBox 7"/>
+          <p:cNvSpPr txBox="1"/>
+          <p:nvPr/>
+        </p:nvSpPr>
+        <p:spPr>
+          <a:xfrm>
+            <a:off x="6958583" y="2468880"/>
+            <a:ext cx="4215383" cy="640080"/>
+          </a:xfrm>
+          <a:prstGeom prst="rect">
+            <a:avLst/>
+          </a:prstGeom>
+          <a:noFill/>
+        </p:spPr>
+        <p:txBody>
+          <a:bodyPr wrap="square" anchor="t" lIns="0" rIns="0" tIns="0" bIns="0">
+            <a:spAutoFit/>
+          </a:bodyPr>
+          <a:lstStyle/>
+          <a:p>
+            <a:pPr algn="l"/>
+            <a:r>
+              <a:rPr sz="1250" b="0" i="0">
                 <a:solidFill>
                   <a:srgbClr val="3A4556"/>
                 </a:solidFill>
                 <a:latin typeface="IBM Plex Sans"/>
               </a:rPr>
-              <a:t>GRAIMATTER green paper. </a:t>
-            </a:r>
-            <a:r>
-              <a:rPr sz="1350" b="0" i="0">
+              <a:t>aml_report.txt: evasion, extraction, backdoor.</a:t>
+            </a:r>
+          </a:p>
+        </p:txBody>
+      </p:sp>
+      <p:sp>
+        <p:nvSpPr>
+          <p:cNvPr id="9" name="Rounded Rectangle 8"/>
+          <p:cNvSpPr/>
+          <p:nvPr/>
+        </p:nvSpPr>
+        <p:spPr>
+          <a:xfrm>
+            <a:off x="6757416" y="3337560"/>
+            <a:ext cx="4617720" cy="1188720"/>
+          </a:xfrm>
+          <a:prstGeom prst="roundRect">
+            <a:avLst>
+              <a:gd name="adj" fmla="val 8000"/>
+            </a:avLst>
+          </a:prstGeom>
+          <a:solidFill>
+            <a:srgbClr val="FDFCF9"/>
+          </a:solidFill>
+          <a:ln w="12700">
+            <a:solidFill>
+              <a:srgbClr val="E2DFD6"/>
+            </a:solidFill>
+          </a:ln>
+          <a:effectLst/>
+        </p:spPr>
+        <p:txBody>
+          <a:bodyPr rtlCol="0" anchor="ctr"/>
+          <a:lstStyle/>
+          <a:p>
+            <a:pPr algn="ctr"/>
+          </a:p>
+        </p:txBody>
+      </p:sp>
+      <p:sp>
+        <p:nvSpPr>
+          <p:cNvPr id="10" name="TextBox 9"/>
+          <p:cNvSpPr txBox="1"/>
+          <p:nvPr/>
+        </p:nvSpPr>
+        <p:spPr>
+          <a:xfrm>
+            <a:off x="6958583" y="3520440"/>
+            <a:ext cx="4215383" cy="365760"/>
+          </a:xfrm>
+          <a:prstGeom prst="rect">
+            <a:avLst/>
+          </a:prstGeom>
+          <a:noFill/>
+        </p:spPr>
+        <p:txBody>
+          <a:bodyPr wrap="square" anchor="t" lIns="0" rIns="0" tIns="0" bIns="0">
+            <a:spAutoFit/>
+          </a:bodyPr>
+          <a:lstStyle/>
+          <a:p>
+            <a:pPr algn="l"/>
+            <a:r>
+              <a:rPr sz="1600" b="1" i="0">
+                <a:solidFill>
+                  <a:srgbClr val="0F1B2D"/>
+                </a:solidFill>
+                <a:latin typeface="IBM Plex Sans"/>
+              </a:rPr>
+              <a:t>Demo 1 · seconds</a:t>
+            </a:r>
+          </a:p>
+        </p:txBody>
+      </p:sp>
+      <p:sp>
+        <p:nvSpPr>
+          <p:cNvPr id="11" name="TextBox 10"/>
+          <p:cNvSpPr txBox="1"/>
+          <p:nvPr/>
+        </p:nvSpPr>
+        <p:spPr>
+          <a:xfrm>
+            <a:off x="6958583" y="3794760"/>
+            <a:ext cx="4215383" cy="640080"/>
+          </a:xfrm>
+          <a:prstGeom prst="rect">
+            <a:avLst/>
+          </a:prstGeom>
+          <a:noFill/>
+        </p:spPr>
+        <p:txBody>
+          <a:bodyPr wrap="square" anchor="t" lIns="0" rIns="0" tIns="0" bIns="0">
+            <a:spAutoFit/>
+          </a:bodyPr>
+          <a:lstStyle/>
+          <a:p>
+            <a:pPr algn="l"/>
+            <a:r>
+              <a:rPr sz="1250" b="0" i="0">
                 <a:solidFill>
                   <a:srgbClr val="3A4556"/>
                 </a:solidFill>
                 <a:latin typeface="IBM Plex Sans"/>
               </a:rPr>
-              <a:t>Recommendations for disclosure control of trained ML models from TREs. DARE UK, September 2022 (in this repository). SACRO-ML: github.com/AI-SDC/SACRO-ML.</a:t>
+              <a:t>demo_report.txt, data dictionary, register entry, pipeline snapshot, release reports.</a:t>
+            </a:r>
+          </a:p>
+        </p:txBody>
+      </p:sp>
+      <p:sp>
+        <p:nvSpPr>
+          <p:cNvPr id="12" name="Rounded Rectangle 11"/>
+          <p:cNvSpPr/>
+          <p:nvPr/>
+        </p:nvSpPr>
+        <p:spPr>
+          <a:xfrm>
+            <a:off x="6757416" y="4663440"/>
+            <a:ext cx="4617720" cy="1234440"/>
+          </a:xfrm>
+          <a:prstGeom prst="roundRect">
+            <a:avLst>
+              <a:gd name="adj" fmla="val 8000"/>
+            </a:avLst>
+          </a:prstGeom>
+          <a:solidFill>
+            <a:srgbClr val="FDFCF9"/>
+          </a:solidFill>
+          <a:ln w="12700">
+            <a:solidFill>
+              <a:srgbClr val="E2DFD6"/>
+            </a:solidFill>
+          </a:ln>
+          <a:effectLst/>
+        </p:spPr>
+        <p:txBody>
+          <a:bodyPr rtlCol="0" anchor="ctr"/>
+          <a:lstStyle/>
+          <a:p>
+            <a:pPr algn="ctr"/>
+          </a:p>
+        </p:txBody>
+      </p:sp>
+      <p:sp>
+        <p:nvSpPr>
+          <p:cNvPr id="13" name="TextBox 12"/>
+          <p:cNvSpPr txBox="1"/>
+          <p:nvPr/>
+        </p:nvSpPr>
+        <p:spPr>
+          <a:xfrm>
+            <a:off x="6958583" y="4846320"/>
+            <a:ext cx="4215383" cy="365760"/>
+          </a:xfrm>
+          <a:prstGeom prst="rect">
+            <a:avLst/>
+          </a:prstGeom>
+          <a:noFill/>
+        </p:spPr>
+        <p:txBody>
+          <a:bodyPr wrap="square" anchor="t" lIns="0" rIns="0" tIns="0" bIns="0">
+            <a:spAutoFit/>
+          </a:bodyPr>
+          <a:lstStyle/>
+          <a:p>
+            <a:pPr algn="l"/>
+            <a:r>
+              <a:rPr sz="1600" b="1" i="0">
+                <a:solidFill>
+                  <a:srgbClr val="0F1B2D"/>
+                </a:solidFill>
+                <a:latin typeface="IBM Plex Sans"/>
+              </a:rPr>
+              <a:t>Demo 2 · a few minutes</a:t>
+            </a:r>
+          </a:p>
+        </p:txBody>
+      </p:sp>
+      <p:sp>
+        <p:nvSpPr>
+          <p:cNvPr id="14" name="TextBox 13"/>
+          <p:cNvSpPr txBox="1"/>
+          <p:nvPr/>
+        </p:nvSpPr>
+        <p:spPr>
+          <a:xfrm>
+            <a:off x="6958583" y="5120640"/>
+            <a:ext cx="4215383" cy="685800"/>
+          </a:xfrm>
+          <a:prstGeom prst="rect">
+            <a:avLst/>
+          </a:prstGeom>
+          <a:noFill/>
+        </p:spPr>
+        <p:txBody>
+          <a:bodyPr wrap="square" anchor="t" lIns="0" rIns="0" tIns="0" bIns="0">
+            <a:spAutoFit/>
+          </a:bodyPr>
+          <a:lstStyle/>
+          <a:p>
+            <a:pPr algn="l"/>
+            <a:r>
+              <a:rPr sz="1250" b="0" i="0">
+                <a:solidFill>
+                  <a:srgbClr val="3A4556"/>
+                </a:solidFill>
+                <a:latin typeface="IBM Plex Sans"/>
+              </a:rPr>
+              <a:t>sacroml/sacroml_report.txt; report.json and report.pdf per attack.</a:t>
+            </a:r>
+          </a:p>
+        </p:txBody>
+      </p:sp>
+      <p:sp>
+        <p:nvSpPr>
+          <p:cNvPr id="15" name="TextBox 14"/>
+          <p:cNvSpPr txBox="1"/>
+          <p:nvPr/>
+        </p:nvSpPr>
+        <p:spPr>
+          <a:xfrm>
+            <a:off x="813816" y="6236208"/>
+            <a:ext cx="10561320" cy="274320"/>
+          </a:xfrm>
+          <a:prstGeom prst="rect">
+            <a:avLst/>
+          </a:prstGeom>
+          <a:noFill/>
+        </p:spPr>
+        <p:txBody>
+          <a:bodyPr wrap="square" anchor="t" lIns="0" rIns="0" tIns="0" bIns="0">
+            <a:spAutoFit/>
+          </a:bodyPr>
+          <a:lstStyle/>
+          <a:p>
+            <a:pPr algn="l"/>
+            <a:r>
+              <a:rPr sz="1200" b="0" i="0">
+                <a:solidFill>
+                  <a:srgbClr val="5F6979"/>
+                </a:solidFill>
+                <a:latin typeface="IBM Plex Sans"/>
+              </a:rPr>
+              <a:t>Setup details: README.md. Section notes: demo/README.md. Guides: docs/guide/ (English and Spanish).</a:t>
             </a:r>
           </a:p>
         </p:txBody>
@@ -22523,6 +23340,269 @@
                 <a:latin typeface="IBM Plex Sans"/>
               </a:rPr>
               <a:t>NIST AI 100-2e2025 §2.1.1 (stages) and §2.1.3 (capabilities). GRAIMATTER band: §10.1 of the green paper.</a:t>
+            </a:r>
+          </a:p>
+        </p:txBody>
+      </p:sp>
+    </p:spTree>
+  </p:cSld>
+  <p:clrMapOvr>
+    <a:masterClrMapping/>
+  </p:clrMapOvr>
+</p:sld>
+</file>
+
+<file path=ppt/slides/slide40.xml><?xml version="1.0" encoding="utf-8"?>
+<p:sld xmlns:a="http://schemas.openxmlformats.org/drawingml/2006/main" xmlns:p="http://schemas.openxmlformats.org/presentationml/2006/main" xmlns:r="http://schemas.openxmlformats.org/officeDocument/2006/relationships">
+  <p:cSld>
+    <p:bg>
+      <p:bgPr>
+        <a:solidFill>
+          <a:srgbClr val="F6F5F0"/>
+        </a:solidFill>
+        <a:effectLst/>
+      </p:bgPr>
+    </p:bg>
+    <p:spTree>
+      <p:nvGrpSpPr>
+        <p:cNvPr id="1" name=""/>
+        <p:cNvGrpSpPr/>
+        <p:nvPr/>
+      </p:nvGrpSpPr>
+      <p:grpSpPr/>
+      <p:sp>
+        <p:nvSpPr>
+          <p:cNvPr id="2" name="Title 1"/>
+          <p:cNvSpPr>
+            <a:spLocks noGrp="1"/>
+          </p:cNvSpPr>
+          <p:nvPr>
+            <p:ph type="title"/>
+          </p:nvPr>
+        </p:nvSpPr>
+        <p:spPr>
+          <a:xfrm>
+            <a:off x="813816" y="1207008"/>
+            <a:ext cx="10561320" cy="868680"/>
+          </a:xfrm>
+        </p:spPr>
+        <p:txBody>
+          <a:bodyPr wrap="square" anchor="t" lIns="0" rIns="0" tIns="0" bIns="0"/>
+          <a:lstStyle/>
+          <a:p>
+            <a:pPr algn="l"/>
+            <a:r>
+              <a:rPr sz="3000" b="1">
+                <a:solidFill>
+                  <a:srgbClr val="0F1B2D"/>
+                </a:solidFill>
+                <a:latin typeface="IBM Plex Sans"/>
+              </a:rPr>
+              <a:t>Read further</a:t>
+            </a:r>
+          </a:p>
+        </p:txBody>
+      </p:sp>
+      <p:sp>
+        <p:nvSpPr>
+          <p:cNvPr id="3" name="TextBox 2"/>
+          <p:cNvSpPr txBox="1"/>
+          <p:nvPr/>
+        </p:nvSpPr>
+        <p:spPr>
+          <a:xfrm>
+            <a:off x="813816" y="813816"/>
+            <a:ext cx="10561320" cy="274320"/>
+          </a:xfrm>
+          <a:prstGeom prst="rect">
+            <a:avLst/>
+          </a:prstGeom>
+          <a:noFill/>
+        </p:spPr>
+        <p:txBody>
+          <a:bodyPr wrap="square" anchor="t" lIns="0" rIns="0" tIns="0" bIns="0">
+            <a:spAutoFit/>
+          </a:bodyPr>
+          <a:lstStyle/>
+          <a:p>
+            <a:pPr algn="l"/>
+            <a:r>
+              <a:rPr sz="1200" b="0" i="0">
+                <a:solidFill>
+                  <a:srgbClr val="B4521A"/>
+                </a:solidFill>
+                <a:latin typeface="Consolas"/>
+              </a:rPr>
+              <a:t>REFERENCES</a:t>
+            </a:r>
+          </a:p>
+        </p:txBody>
+      </p:sp>
+      <p:sp>
+        <p:nvSpPr>
+          <p:cNvPr id="4" name="TextBox 3"/>
+          <p:cNvSpPr txBox="1"/>
+          <p:nvPr/>
+        </p:nvSpPr>
+        <p:spPr>
+          <a:xfrm>
+            <a:off x="813816" y="1920240"/>
+            <a:ext cx="10561320" cy="4206240"/>
+          </a:xfrm>
+          <a:prstGeom prst="rect">
+            <a:avLst/>
+          </a:prstGeom>
+          <a:noFill/>
+        </p:spPr>
+        <p:txBody>
+          <a:bodyPr wrap="square" anchor="t" lIns="0" rIns="0" tIns="0" bIns="0">
+            <a:spAutoFit/>
+          </a:bodyPr>
+          <a:lstStyle/>
+          <a:p>
+            <a:pPr algn="l"/>
+            <a:r>
+              <a:rPr sz="1350" b="1" i="0">
+                <a:solidFill>
+                  <a:srgbClr val="3A4556"/>
+                </a:solidFill>
+                <a:latin typeface="IBM Plex Sans"/>
+              </a:rPr>
+              <a:t>NIST AI 100-2e2025. </a:t>
+            </a:r>
+            <a:r>
+              <a:rPr sz="1350" b="0" i="0">
+                <a:solidFill>
+                  <a:srgbClr val="3A4556"/>
+                </a:solidFill>
+                <a:latin typeface="IBM Plex Sans"/>
+              </a:rPr>
+              <a:t>Vassilev, Oprea, Fordyce, Anderson, Davies, Hamin. Adversarial Machine Learning: A Taxonomy and Terminology of Attacks and Mitigations. March 2025. doi:10.6028/NIST.AI.100-2e2025 (in this repository).</a:t>
+            </a:r>
+          </a:p>
+          <a:p>
+            <a:pPr algn="l">
+              <a:spcBef>
+                <a:spcPts val="600"/>
+              </a:spcBef>
+            </a:pPr>
+            <a:r>
+              <a:rPr sz="1350" b="1" i="0">
+                <a:solidFill>
+                  <a:srgbClr val="3A4556"/>
+                </a:solidFill>
+                <a:latin typeface="IBM Plex Sans"/>
+              </a:rPr>
+              <a:t>MITRE ATLAS. </a:t>
+            </a:r>
+            <a:r>
+              <a:rPr sz="1350" b="0" i="0">
+                <a:solidFill>
+                  <a:srgbClr val="3A4556"/>
+                </a:solidFill>
+                <a:latin typeface="IBM Plex Sans"/>
+              </a:rPr>
+              <a:t>atlas.mitre.org, data release 2026.09.</a:t>
+            </a:r>
+          </a:p>
+          <a:p>
+            <a:pPr algn="l">
+              <a:spcBef>
+                <a:spcPts val="600"/>
+              </a:spcBef>
+            </a:pPr>
+            <a:r>
+              <a:rPr sz="1350" b="1" i="0">
+                <a:solidFill>
+                  <a:srgbClr val="3A4556"/>
+                </a:solidFill>
+                <a:latin typeface="IBM Plex Sans"/>
+              </a:rPr>
+              <a:t>OWASP. </a:t>
+            </a:r>
+            <a:r>
+              <a:rPr sz="1350" b="0" i="0">
+                <a:solidFill>
+                  <a:srgbClr val="3A4556"/>
+                </a:solidFill>
+                <a:latin typeface="IBM Plex Sans"/>
+              </a:rPr>
+              <a:t>Machine Learning Security Top 10 (2023, draft); Top 10 for LLM Applications 2025.</a:t>
+            </a:r>
+          </a:p>
+          <a:p>
+            <a:pPr algn="l">
+              <a:spcBef>
+                <a:spcPts val="600"/>
+              </a:spcBef>
+            </a:pPr>
+            <a:r>
+              <a:rPr sz="1350" b="1" i="0">
+                <a:solidFill>
+                  <a:srgbClr val="3A4556"/>
+                </a:solidFill>
+                <a:latin typeface="IBM Plex Sans"/>
+              </a:rPr>
+              <a:t>EU. </a:t>
+            </a:r>
+            <a:r>
+              <a:rPr sz="1350" b="0" i="0">
+                <a:solidFill>
+                  <a:srgbClr val="3A4556"/>
+                </a:solidFill>
+                <a:latin typeface="IBM Plex Sans"/>
+              </a:rPr>
+              <a:t>Regulation (EU) 2024/1689 (AI Act), Art. 15; Regulation (EU) 2026/1744 (Digital Omnibus on AI); EDPB Opinion 28/2024 on AI models.</a:t>
+            </a:r>
+          </a:p>
+          <a:p>
+            <a:pPr algn="l">
+              <a:spcBef>
+                <a:spcPts val="600"/>
+              </a:spcBef>
+            </a:pPr>
+            <a:r>
+              <a:rPr sz="1350" b="1" i="0">
+                <a:solidFill>
+                  <a:srgbClr val="3A4556"/>
+                </a:solidFill>
+                <a:latin typeface="IBM Plex Sans"/>
+              </a:rPr>
+              <a:t>UK. </a:t>
+            </a:r>
+            <a:r>
+              <a:rPr sz="1350" b="0" i="0">
+                <a:solidFill>
+                  <a:srgbClr val="3A4556"/>
+                </a:solidFill>
+                <a:latin typeface="IBM Plex Sans"/>
+              </a:rPr>
+              <a:t>DSIT Code of Practice for the Cyber Security of AI (Jan 2025); ETSI EN 304 223 (Jan 2026); NCSC and CISA, Guidelines for secure AI system development (Nov 2023).</a:t>
+            </a:r>
+          </a:p>
+          <a:p>
+            <a:pPr algn="l">
+              <a:spcBef>
+                <a:spcPts val="600"/>
+              </a:spcBef>
+            </a:pPr>
+            <a:r>
+              <a:rPr sz="1350" b="1" i="0">
+                <a:solidFill>
+                  <a:srgbClr val="3A4556"/>
+                </a:solidFill>
+                <a:latin typeface="IBM Plex Sans"/>
+              </a:rPr>
+              <a:t>GRAIMATTER green paper. </a:t>
+            </a:r>
+            <a:r>
+              <a:rPr sz="1350" b="0" i="0">
+                <a:solidFill>
+                  <a:srgbClr val="3A4556"/>
+                </a:solidFill>
+                <a:latin typeface="IBM Plex Sans"/>
+              </a:rPr>
+              <a:t>Recommendations for disclosure control of trained ML models from TREs. DARE UK, September 2022 (in this repository). SACRO-ML: github.com/AI-SDC/SACRO-ML.</a:t>
             </a:r>
           </a:p>
         </p:txBody>

</xml_diff>

<commit_message>
Frame the NIST objectives as the CIA triad
NIST's availability, integrity and privacy objectives are the classic
confidentiality, integrity and availability of information security;
NIST explains in §2.1.2 that it says privacy because the term covers both
the model's confidentiality and the people in the training data, and the
EU AI Act calls the same attacks confidentiality attacks. Supply chain is
a route in, not a fourth property.

Adds a paragraph to guide §2.1 and a correspondence table to Appendix B
(English and Spanish), the framing to presenter-guide slides 5, 9 and 16,
and a footer line and speaker note on deck slide 5.
</commit_message>
<xml_diff>
--- a/docs/Adversarial_ML.pptx
+++ b/docs/Adversarial_ML.pptx
@@ -2991,7 +2991,7 @@
           <a:lstStyle/>
           <a:p>
             <a:r>
-              <a:t>The taxonomy starts from what the attacker wants. Availability: make the model useless for everyone, by poisoning or by inputs that make it slow. Integrity: make it give the answer the attacker wants, by evasion at deployment or by targeted and backdoor poisoning at training. Privacy: learn something that should stay hidden, about the training data or about the model itself. Each class has an identifier, so a test report can say NISTAML.033 rather than 'some privacy attack'. Highlighted boxes are the ones our three demos run.</a:t>
+              <a:t>The taxonomy starts from what the attacker wants, and the three objectives are the classic CIA triad: availability, integrity and confidentiality. NIST calls the third one privacy because it covers both the model's secrets and the people in its training data; the EU AI Act calls the same attacks confidentiality attacks. Supply chain is a route in, not a fourth goal. Availability: make the model useless for everyone, by poisoning or by inputs that make it slow. Integrity: make it give the answer the attacker wants, by evasion at deployment or by targeted and backdoor poisoning at training. Privacy: learn something that should stay hidden, about the training data or about the model itself. Each class has an identifier, so a test report can say NISTAML.033 rather than 'some privacy attack'. Highlighted boxes are the ones our three demos run.</a:t>
             </a:r>
           </a:p>
         </p:txBody>
@@ -23755,7 +23755,7 @@
                 </a:solidFill>
                 <a:latin typeface="IBM Plex Sans"/>
               </a:rPr>
-              <a:t>NIST AI 100-2e2025, Predictive AI and Generative AI Taxonomy Index (pp. x-xi) and §2.1.2.</a:t>
+              <a:t>The CIA triad in NIST's words: privacy = confidentiality (§2.1.2). NIST AI 100-2e2025, Taxonomy Index (pp. x-xi) and §2.1.2.</a:t>
             </a:r>
           </a:p>
         </p:txBody>

</xml_diff>

<commit_message>
Shuffle Salem-synth's rows before scoring, and update its numbers
salem_synth_membership() passed the target rows with all members first, and
the tail metrics sort stably, so every tied score was ranked in favour of the
members. The Salem tail numbers were inflated: TPR at 10% FPR 0.514 and FDIF
1.000 on the unconstrained tree, FDIF 0.280 on the wrapped one. The rows are
now shuffled with a separate generator, so no other draw in demo 1 changes.

New Salem numbers: unconstrained tree TPR at 10% FPR 0.186, FDIF 0.660;
wrapped tree TPR at 10% FPR 0.118, FDIF 0.160 (p = 0.027). The quiet-failure
warning still prints. Worst-case numbers, decisions and gate verdicts are
unchanged.

Updated: demo_report.txt, the technical, presenter and demo guides (EN and
ES), the README, figure 7 (EN and ES) and slide 29 of the deck, regenerated
with make_figures.py and make_deck.py.
</commit_message>
<xml_diff>
--- a/docs/Adversarial_ML.pptx
+++ b/docs/Adversarial_ML.pptx
@@ -2012,7 +2012,7 @@
           <a:lstStyle/>
           <a:p>
             <a:r>
-              <a:t>On the same wrapped tree we also run Salem-synth, where the attacker trains a shadow model on similar data rather than on the TRE's own tables. Its AUC is 0.512, close to chance. But its FDIF is 0.280 with p = 0.003, and TPR at 10% FPR is 0.252: members pile up in the extreme scores. This is exactly the Appendix F warning: an average metric can hide a tail. The demo's export rule follows the worst-case attack, whose FDIF is 0.020, so it still releases. A data controller who cares about the tail could refuse.</a:t>
+              <a:t>On the same wrapped tree we also run Salem-synth, where the attacker trains a shadow model on similar data rather than on the TRE's own tables. Its AUC is 0.512, close to chance. But its FDIF is 0.160 with p = 0.027: the top tenth of its scores holds clearly more members than the bottom tenth. This is exactly the Appendix F warning: an average metric can hide a tail. The demo's export rule follows the worst-case attack, whose FDIF is 0.020, so it still releases. A data controller who cares about the tail could refuse.</a:t>
             </a:r>
           </a:p>
         </p:txBody>
@@ -18112,7 +18112,7 @@
                 </a:solidFill>
                 <a:latin typeface="IBM Plex Sans"/>
               </a:rPr>
-              <a:t>The quiet failure: AUC near 0.5, but FDIF 0.280</a:t>
+              <a:t>The quiet failure: AUC near 0.5, but FDIF 0.160</a:t>
             </a:r>
           </a:p>
         </p:txBody>

</xml_diff>

<commit_message>
Credit demo 4 for NISTAML.051 and OWASP ML06
Demo 4 covers the supply chain, but three places still showed a dash
for it: the .051 row of the Appendix B table and the ML06 row of the
OWASP table in the technical guide, and slide 16, whose ML06 row and
presenter-guide description still said ML06 was not shown. All now
point to demo 4, in EN and ES. The deck is regenerated with
make_deck.py; only slide 16 changes.
</commit_message>
<xml_diff>
--- a/docs/Adversarial_ML.pptx
+++ b/docs/Adversarial_ML.pptx
@@ -1032,7 +1032,7 @@
           <a:lstStyle/>
           <a:p>
             <a:r>
-              <a:t>OWASP's machine-learning list is short and practical. It overlaps NIST's privacy branch heavily: model inversion and membership inference are two of the ten, and model theft is a third. Model poisoning, ML10, means manipulating the model's parameters, which is what demo 1's tamper check catches. The list is marked as a draft and dates from 2023, so treat it as a checklist rather than a standard. The LLM list from 2025 is more current and is the one most teams building chat or agent products use.</a:t>
+              <a:t>OWASP's machine-learning list is short and practical. It overlaps NIST's privacy branch heavily: model inversion and membership inference are two of the ten, and model theft is a third. Model poisoning, ML10, means manipulating the model's parameters, which is what demo 1's tamper check catches, and AI supply chain attacks, ML06, are demo 4. The list is marked as a draft and dates from 2023, so treat it as a checklist rather than a standard. The LLM list from 2025 is more current and is the one most teams building chat or agent products use.</a:t>
             </a:r>
           </a:p>
         </p:txBody>
@@ -10577,13 +10577,13 @@
                           </a:solidFill>
                           <a:latin typeface="IBM Plex Sans"/>
                         </a:rPr>
-                        <a:t>–</a:t>
+                        <a:t>demo 4</a:t>
                       </a:r>
                     </a:p>
                   </a:txBody>
                   <a:tcPr marL="91440" marR="91440" marT="36576" marB="36576" anchor="ctr">
                     <a:solidFill>
-                      <a:srgbClr val="F1EFE8"/>
+                      <a:srgbClr val="FBE9DC"/>
                     </a:solidFill>
                   </a:tcPr>
                 </a:tc>
@@ -10977,7 +10977,7 @@
                 </a:solidFill>
                 <a:latin typeface="IBM Plex Sans"/>
               </a:rPr>
-              <a:t>ML03 and ML04 are what GRAIMATTER tests before release. ML10 is demo 1's check for edits after fit(). ML01, ML02 and ML05 are demo 3. The LLM list is on the generative-AI slide.</a:t>
+              <a:t>ML03 and ML04 are what GRAIMATTER tests before release. ML10 is demo 1's check for edits after fit(). ML01, ML02 and ML05 are demo 3, ML06 is demo 4. The LLM list is on the generative-AI slide.</a:t>
             </a:r>
           </a:p>
         </p:txBody>

</xml_diff>